<commit_message>
Just a link, an itty bitty link
</commit_message>
<xml_diff>
--- a/reports/COVID_Capstone3_Presentation.pptx
+++ b/reports/COVID_Capstone3_Presentation.pptx
@@ -145,197 +145,16 @@
           <a:chExt cx="0" cy="0"/>
         </a:xfrm>
       </p:grpSpPr>
-      <p:sp>
-        <p:nvSpPr>
-          <p:cNvPr id="2" name="Header Placeholder 1"/>
-          <p:cNvSpPr>
-            <a:spLocks noGrp="1"/>
-          </p:cNvSpPr>
-          <p:nvPr>
-            <p:ph type="hdr" sz="quarter"/>
-          </p:nvPr>
-        </p:nvSpPr>
-        <p:spPr>
-          <a:xfrm>
-            <a:off x="0" y="0"/>
-            <a:ext cx="2971800" cy="458788"/>
-          </a:xfrm>
-          <a:prstGeom prst="rect">
-            <a:avLst/>
-          </a:prstGeom>
-        </p:spPr>
-        <p:txBody>
-          <a:bodyPr vert="horz" lIns="91440" tIns="45720" rIns="91440" bIns="45720" rtlCol="0">
-            <a:normAutofit/>
-          </a:bodyPr>
-          <a:lstStyle/>
-          <a:p>
-            <a:endParaRPr lang="en-US"/>
-          </a:p>
-        </p:txBody>
-      </p:sp>
-      <p:sp>
-        <p:nvSpPr>
-          <p:cNvPr id="3" name="Slide Image Placeholder 2"/>
-          <p:cNvSpPr>
-            <a:spLocks noGrp="1" noRot="1" noChangeAspect="1"/>
-          </p:cNvSpPr>
-          <p:nvPr>
-            <p:ph type="sldImg" idx="1"/>
-          </p:nvPr>
-        </p:nvSpPr>
-        <p:spPr>
-          <a:xfrm>
-            <a:off x="685800" y="838200"/>
-            <a:ext cx="5486400" cy="3086100"/>
-          </a:xfrm>
-          <a:prstGeom prst="rect">
-            <a:avLst/>
-          </a:prstGeom>
-          <a:noFill/>
-          <a:ln w="12700">
-            <a:solidFill>
-              <a:schemeClr val="tx1"/>
-            </a:solidFill>
-          </a:ln>
-        </p:spPr>
-        <p:txBody>
-          <a:bodyPr vert="horz" lIns="91440" tIns="45720" rIns="91440" bIns="45720" rtlCol="0" anchor="ctr"/>
-          <a:lstStyle/>
-          <a:p>
-            <a:endParaRPr lang="en-US"/>
-          </a:p>
-        </p:txBody>
-      </p:sp>
-      <p:sp>
-        <p:nvSpPr>
-          <p:cNvPr id="4" name="Notes Placeholder 3"/>
-          <p:cNvSpPr>
-            <a:spLocks noGrp="1"/>
-          </p:cNvSpPr>
-          <p:nvPr>
-            <p:ph type="body" sz="quarter" idx="1"/>
-          </p:nvPr>
-        </p:nvSpPr>
-        <p:spPr>
-          <a:xfrm>
-            <a:off x="685800" y="4114800"/>
-            <a:ext cx="5486400" cy="3600450"/>
-          </a:xfrm>
-          <a:prstGeom prst="rect">
-            <a:avLst/>
-          </a:prstGeom>
-        </p:spPr>
-        <p:txBody>
-          <a:bodyPr vert="horz" lIns="91440" tIns="45720" rIns="91440" bIns="45720" rtlCol="0">
-            <a:normAutofit/>
-          </a:bodyPr>
-          <a:lstStyle/>
-          <a:p>
-            <a:pPr lvl="0"/>
-            <a:r>
-              <a:rPr lang="en-US"/>
-              <a:t>Click to edit Master text styles</a:t>
-            </a:r>
-          </a:p>
-        </p:txBody>
-      </p:sp>
-      <p:sp>
-        <p:nvSpPr>
-          <p:cNvPr id="5" name="Footer Placeholder 4"/>
-          <p:cNvSpPr>
-            <a:spLocks noGrp="1"/>
-          </p:cNvSpPr>
-          <p:nvPr>
-            <p:ph type="ftr" sz="quarter" idx="2"/>
-          </p:nvPr>
-        </p:nvSpPr>
-        <p:spPr>
-          <a:xfrm>
-            <a:off x="0" y="8685213"/>
-            <a:ext cx="2971800" cy="458787"/>
-          </a:xfrm>
-          <a:prstGeom prst="rect">
-            <a:avLst/>
-          </a:prstGeom>
-        </p:spPr>
-        <p:txBody>
-          <a:bodyPr vert="horz" lIns="91440" tIns="45720" rIns="91440" bIns="45720" rtlCol="0" anchor="b">
-            <a:normAutofit/>
-          </a:bodyPr>
-          <a:lstStyle/>
-          <a:p>
-            <a:endParaRPr lang="en-US"/>
-          </a:p>
-        </p:txBody>
-      </p:sp>
-      <p:sp>
-        <p:nvSpPr>
-          <p:cNvPr id="6" name="Date Placeholder 5"/>
-          <p:cNvSpPr>
-            <a:spLocks noGrp="1"/>
-          </p:cNvSpPr>
-          <p:nvPr>
-            <p:ph type="dt" idx="10"/>
-          </p:nvPr>
-        </p:nvSpPr>
-        <p:spPr>
-          <a:xfrm>
-            <a:off x="3884613" y="0"/>
-            <a:ext cx="2971800" cy="458788"/>
-          </a:xfrm>
-          <a:prstGeom prst="rect">
-            <a:avLst/>
-          </a:prstGeom>
-        </p:spPr>
-        <p:txBody>
-          <a:bodyPr vert="horz" lIns="91440" tIns="45720" rIns="91440" bIns="45720" rtlCol="0" anchor="t"/>
-          <a:lstStyle/>
-          <a:p>
-            <a:fld id="{F9364F58-7115-4D4E-9E7D-8F1D3B8E9C7A}" type="datetimeNoYear">
-              <a:rPr lang="en-US"/>
-              <a:t>3/6/26</a:t>
-            </a:fld>
-            <a:endParaRPr lang="en-US"/>
-          </a:p>
-        </p:txBody>
-      </p:sp>
-      <p:sp>
-        <p:nvSpPr>
-          <p:cNvPr id="7" name="Slide Number Placeholder 6"/>
-          <p:cNvSpPr>
-            <a:spLocks noGrp="1"/>
-          </p:cNvSpPr>
-          <p:nvPr>
-            <p:ph type="sldNum" sz="quarter" idx="11"/>
-          </p:nvPr>
-        </p:nvSpPr>
-        <p:spPr>
-          <a:xfrm>
-            <a:off x="3884613" y="8685213"/>
-            <a:ext cx="2971800" cy="458787"/>
-          </a:xfrm>
-          <a:prstGeom prst="rect">
-            <a:avLst/>
-          </a:prstGeom>
-        </p:spPr>
-        <p:txBody>
-          <a:bodyPr vert="horz" lIns="91440" tIns="45720" rIns="91440" bIns="45720" rtlCol="0" anchor="b"/>
-          <a:lstStyle/>
-          <a:p>
-            <a:fld id="{CE5E9CC1-C706-0F49-92D6-E571CC5EAB2E}" type="slidenum">
-              <a:rPr lang="en-US"/>
-              <a:t>‹#›</a:t>
-            </a:fld>
-            <a:endParaRPr lang="en-US"/>
-          </a:p>
-        </p:txBody>
-      </p:sp>
     </p:spTree>
+    <p:extLst>
+      <p:ext uri="{BB962C8B-B14F-4D97-AF65-F5344CB8AC3E}">
+        <p14:creationId xmlns:p14="http://schemas.microsoft.com/office/powerpoint/2010/main" val="3025472555"/>
+      </p:ext>
+    </p:extLst>
   </p:cSld>
   <p:clrMap bg1="lt1" tx1="dk1" bg2="lt2" tx2="dk2" accent1="accent1" accent2="accent2" accent3="accent3" accent4="accent4" accent5="accent5" accent6="accent6" hlink="hlink" folHlink="folHlink"/>
   <p:notesStyle>
-    <a:lvl1pPr marL="0" indent="0" algn="l" defTabSz="914400" rtl="0" eaLnBrk="1" latinLnBrk="0" hangingPunct="1">
+    <a:lvl1pPr marL="0" algn="l" defTabSz="914400" rtl="0" eaLnBrk="1" latinLnBrk="0" hangingPunct="1">
       <a:defRPr sz="1200" kern="1200">
         <a:solidFill>
           <a:schemeClr val="tx1"/>
@@ -345,7 +164,7 @@
         <a:cs typeface="+mn-cs"/>
       </a:defRPr>
     </a:lvl1pPr>
-    <a:lvl2pPr marL="457200" indent="0" algn="l" defTabSz="914400" rtl="0" eaLnBrk="1" latinLnBrk="0" hangingPunct="1">
+    <a:lvl2pPr marL="457200" algn="l" defTabSz="914400" rtl="0" eaLnBrk="1" latinLnBrk="0" hangingPunct="1">
       <a:defRPr sz="1200" kern="1200">
         <a:solidFill>
           <a:schemeClr val="tx1"/>
@@ -355,7 +174,7 @@
         <a:cs typeface="+mn-cs"/>
       </a:defRPr>
     </a:lvl2pPr>
-    <a:lvl3pPr marL="914400" indent="0" algn="l" defTabSz="914400" rtl="0" eaLnBrk="1" latinLnBrk="0" hangingPunct="1">
+    <a:lvl3pPr marL="914400" algn="l" defTabSz="914400" rtl="0" eaLnBrk="1" latinLnBrk="0" hangingPunct="1">
       <a:defRPr sz="1200" kern="1200">
         <a:solidFill>
           <a:schemeClr val="tx1"/>
@@ -365,7 +184,7 @@
         <a:cs typeface="+mn-cs"/>
       </a:defRPr>
     </a:lvl3pPr>
-    <a:lvl4pPr marL="1371600" indent="0" algn="l" defTabSz="914400" rtl="0" eaLnBrk="1" latinLnBrk="0" hangingPunct="1">
+    <a:lvl4pPr marL="1371600" algn="l" defTabSz="914400" rtl="0" eaLnBrk="1" latinLnBrk="0" hangingPunct="1">
       <a:defRPr sz="1200" kern="1200">
         <a:solidFill>
           <a:schemeClr val="tx1"/>
@@ -375,7 +194,7 @@
         <a:cs typeface="+mn-cs"/>
       </a:defRPr>
     </a:lvl4pPr>
-    <a:lvl5pPr marL="1828800" indent="0" algn="l" defTabSz="914400" rtl="0" eaLnBrk="1" latinLnBrk="0" hangingPunct="1">
+    <a:lvl5pPr marL="1828800" algn="l" defTabSz="914400" rtl="0" eaLnBrk="1" latinLnBrk="0" hangingPunct="1">
       <a:defRPr sz="1200" kern="1200">
         <a:solidFill>
           <a:schemeClr val="tx1"/>
@@ -385,7 +204,7 @@
         <a:cs typeface="+mn-cs"/>
       </a:defRPr>
     </a:lvl5pPr>
-    <a:lvl6pPr marL="2286000" indent="0" algn="l" defTabSz="914400" rtl="0" eaLnBrk="1" latinLnBrk="0" hangingPunct="1">
+    <a:lvl6pPr marL="2286000" algn="l" defTabSz="914400" rtl="0" eaLnBrk="1" latinLnBrk="0" hangingPunct="1">
       <a:defRPr sz="1200" kern="1200">
         <a:solidFill>
           <a:schemeClr val="tx1"/>
@@ -395,7 +214,7 @@
         <a:cs typeface="+mn-cs"/>
       </a:defRPr>
     </a:lvl6pPr>
-    <a:lvl7pPr marL="2743200" indent="0" algn="l" defTabSz="914400" rtl="0" eaLnBrk="1" latinLnBrk="0" hangingPunct="1">
+    <a:lvl7pPr marL="2743200" algn="l" defTabSz="914400" rtl="0" eaLnBrk="1" latinLnBrk="0" hangingPunct="1">
       <a:defRPr sz="1200" kern="1200">
         <a:solidFill>
           <a:schemeClr val="tx1"/>
@@ -405,7 +224,7 @@
         <a:cs typeface="+mn-cs"/>
       </a:defRPr>
     </a:lvl7pPr>
-    <a:lvl8pPr marL="3200400" indent="0" algn="l" defTabSz="914400" rtl="0" eaLnBrk="1" latinLnBrk="0" hangingPunct="1">
+    <a:lvl8pPr marL="3200400" algn="l" defTabSz="914400" rtl="0" eaLnBrk="1" latinLnBrk="0" hangingPunct="1">
       <a:defRPr sz="1200" kern="1200">
         <a:solidFill>
           <a:schemeClr val="tx1"/>
@@ -415,7 +234,7 @@
         <a:cs typeface="+mn-cs"/>
       </a:defRPr>
     </a:lvl8pPr>
-    <a:lvl9pPr marL="3657600" indent="0" algn="l" defTabSz="914400" rtl="0" eaLnBrk="1" latinLnBrk="0" hangingPunct="1">
+    <a:lvl9pPr marL="3657600" algn="l" defTabSz="914400" rtl="0" eaLnBrk="1" latinLnBrk="0" hangingPunct="1">
       <a:defRPr sz="1200" kern="1200">
         <a:solidFill>
           <a:schemeClr val="tx1"/>
@@ -1575,7 +1394,7 @@
           <a:p>
             <a:fld id="{48A87A34-81AB-432B-8DAE-1953F412C126}" type="datetimeFigureOut">
               <a:rPr lang="en-US" dirty="0"/>
-              <a:t>7/31/26</a:t>
+              <a:t>8/2/26</a:t>
             </a:fld>
             <a:endParaRPr lang="en-US"/>
           </a:p>
@@ -1837,7 +1656,7 @@
           <a:p>
             <a:fld id="{48A87A34-81AB-432B-8DAE-1953F412C126}" type="datetimeFigureOut">
               <a:rPr lang="en-US" dirty="0"/>
-              <a:t>7/30/26</a:t>
+              <a:t>8/2/26</a:t>
             </a:fld>
             <a:endParaRPr lang="en-US" dirty="0"/>
           </a:p>
@@ -2028,7 +1847,7 @@
           <a:p>
             <a:fld id="{48A87A34-81AB-432B-8DAE-1953F412C126}" type="datetimeFigureOut">
               <a:rPr lang="en-US" dirty="0"/>
-              <a:t>7/30/26</a:t>
+              <a:t>8/2/26</a:t>
             </a:fld>
             <a:endParaRPr lang="en-US" dirty="0"/>
           </a:p>
@@ -2286,7 +2105,7 @@
           <a:p>
             <a:fld id="{48A87A34-81AB-432B-8DAE-1953F412C126}" type="datetimeFigureOut">
               <a:rPr lang="en-US" dirty="0"/>
-              <a:t>7/30/26</a:t>
+              <a:t>8/2/26</a:t>
             </a:fld>
             <a:endParaRPr lang="en-US" dirty="0"/>
           </a:p>
@@ -2715,7 +2534,7 @@
           <a:p>
             <a:fld id="{48A87A34-81AB-432B-8DAE-1953F412C126}" type="datetimeFigureOut">
               <a:rPr lang="en-US" dirty="0"/>
-              <a:t>7/30/26</a:t>
+              <a:t>8/2/26</a:t>
             </a:fld>
             <a:endParaRPr lang="en-US" dirty="0"/>
           </a:p>
@@ -3256,7 +3075,7 @@
           <a:p>
             <a:fld id="{48A87A34-81AB-432B-8DAE-1953F412C126}" type="datetimeFigureOut">
               <a:rPr lang="en-US" dirty="0"/>
-              <a:t>7/30/26</a:t>
+              <a:t>8/2/26</a:t>
             </a:fld>
             <a:endParaRPr lang="en-US" dirty="0"/>
           </a:p>
@@ -3971,7 +3790,7 @@
           <a:p>
             <a:fld id="{48A87A34-81AB-432B-8DAE-1953F412C126}" type="datetimeFigureOut">
               <a:rPr lang="en-US" dirty="0"/>
-              <a:t>7/30/26</a:t>
+              <a:t>8/2/26</a:t>
             </a:fld>
             <a:endParaRPr lang="en-US" dirty="0"/>
           </a:p>
@@ -4136,7 +3955,7 @@
           <a:p>
             <a:fld id="{48A87A34-81AB-432B-8DAE-1953F412C126}" type="datetimeFigureOut">
               <a:rPr lang="en-US" dirty="0"/>
-              <a:t>7/30/26</a:t>
+              <a:t>8/2/26</a:t>
             </a:fld>
             <a:endParaRPr lang="en-US" dirty="0"/>
           </a:p>
@@ -4311,7 +4130,7 @@
           <a:p>
             <a:fld id="{48A87A34-81AB-432B-8DAE-1953F412C126}" type="datetimeFigureOut">
               <a:rPr lang="en-US" dirty="0"/>
-              <a:t>7/30/26</a:t>
+              <a:t>8/2/26</a:t>
             </a:fld>
             <a:endParaRPr lang="en-US" dirty="0"/>
           </a:p>
@@ -4476,7 +4295,7 @@
           <a:p>
             <a:fld id="{48A87A34-81AB-432B-8DAE-1953F412C126}" type="datetimeFigureOut">
               <a:rPr lang="en-US" dirty="0"/>
-              <a:t>7/30/26</a:t>
+              <a:t>8/2/26</a:t>
             </a:fld>
             <a:endParaRPr lang="en-US" dirty="0"/>
           </a:p>
@@ -4721,7 +4540,7 @@
           <a:p>
             <a:fld id="{48A87A34-81AB-432B-8DAE-1953F412C126}" type="datetimeFigureOut">
               <a:rPr lang="en-US" dirty="0"/>
-              <a:t>7/30/26</a:t>
+              <a:t>8/2/26</a:t>
             </a:fld>
             <a:endParaRPr lang="en-US" dirty="0"/>
           </a:p>
@@ -4948,7 +4767,7 @@
           <a:p>
             <a:fld id="{48A87A34-81AB-432B-8DAE-1953F412C126}" type="datetimeFigureOut">
               <a:rPr lang="en-US" dirty="0"/>
-              <a:t>7/30/26</a:t>
+              <a:t>8/2/26</a:t>
             </a:fld>
             <a:endParaRPr lang="en-US" dirty="0"/>
           </a:p>
@@ -5324,7 +5143,7 @@
           <a:p>
             <a:fld id="{48A87A34-81AB-432B-8DAE-1953F412C126}" type="datetimeFigureOut">
               <a:rPr lang="en-US" dirty="0"/>
-              <a:t>7/30/26</a:t>
+              <a:t>8/2/26</a:t>
             </a:fld>
             <a:endParaRPr lang="en-US" dirty="0"/>
           </a:p>
@@ -5437,7 +5256,7 @@
           <a:p>
             <a:fld id="{48A87A34-81AB-432B-8DAE-1953F412C126}" type="datetimeFigureOut">
               <a:rPr lang="en-US" dirty="0"/>
-              <a:t>7/30/26</a:t>
+              <a:t>8/2/26</a:t>
             </a:fld>
             <a:endParaRPr lang="en-US" dirty="0"/>
           </a:p>
@@ -5527,7 +5346,7 @@
           <a:p>
             <a:fld id="{48A87A34-81AB-432B-8DAE-1953F412C126}" type="datetimeFigureOut">
               <a:rPr lang="en-US" dirty="0"/>
-              <a:t>7/30/26</a:t>
+              <a:t>8/2/26</a:t>
             </a:fld>
             <a:endParaRPr lang="en-US" dirty="0"/>
           </a:p>
@@ -5771,7 +5590,7 @@
           <a:p>
             <a:fld id="{48A87A34-81AB-432B-8DAE-1953F412C126}" type="datetimeFigureOut">
               <a:rPr lang="en-US" dirty="0"/>
-              <a:t>7/30/26</a:t>
+              <a:t>8/2/26</a:t>
             </a:fld>
             <a:endParaRPr lang="en-US" dirty="0"/>
           </a:p>
@@ -6046,7 +5865,7 @@
           <a:p>
             <a:fld id="{48A87A34-81AB-432B-8DAE-1953F412C126}" type="datetimeFigureOut">
               <a:rPr lang="en-US" dirty="0"/>
-              <a:t>7/30/26</a:t>
+              <a:t>8/2/26</a:t>
             </a:fld>
             <a:endParaRPr lang="en-US" dirty="0"/>
           </a:p>
@@ -6292,7 +6111,7 @@
             <a:fld id="{48A87A34-81AB-432B-8DAE-1953F412C126}" type="datetimeFigureOut">
               <a:rPr lang="en-US" dirty="0"/>
               <a:pPr/>
-              <a:t>7/31/26</a:t>
+              <a:t>8/2/26</a:t>
             </a:fld>
             <a:endParaRPr lang="en-US"/>
           </a:p>
@@ -10258,109 +10077,14 @@
       </p:grpSpPr>
       <p:sp>
         <p:nvSpPr>
-          <p:cNvPr id="2" name="Title 1"/>
-          <p:cNvSpPr>
-            <a:spLocks noGrp="1"/>
-          </p:cNvSpPr>
-          <p:nvPr>
-            <p:ph type="title"/>
-          </p:nvPr>
-        </p:nvSpPr>
-        <p:spPr>
-          <a:xfrm>
-            <a:off x="1141412" y="220000"/>
-            <a:ext cx="9905998" cy="900000"/>
-          </a:xfrm>
-        </p:spPr>
-        <p:txBody>
-          <a:bodyPr>
-            <a:normAutofit/>
-          </a:bodyPr>
-          <a:lstStyle/>
-          <a:p>
-            <a:r>
-              <a:rPr lang="en-US" sz="2800"/>
-              <a:t>Conclusions &amp; Future Work</a:t>
-            </a:r>
-          </a:p>
-        </p:txBody>
-      </p:sp>
-      <p:sp>
-        <p:nvSpPr>
-          <p:cNvPr id="10" name="Left card"/>
-          <p:cNvSpPr/>
+          <p:cNvPr id="2" name="Closing eyebrow"/>
+          <p:cNvSpPr txBox="1"/>
           <p:nvPr/>
         </p:nvSpPr>
         <p:spPr>
           <a:xfrm>
-            <a:off x="1141412" y="1200000"/>
-            <a:ext cx="4845588" cy="4400000"/>
-          </a:xfrm>
-          <a:prstGeom prst="roundRect">
-            <a:avLst>
-              <a:gd name="adj" fmla="val 3000"/>
-            </a:avLst>
-          </a:prstGeom>
-          <a:solidFill>
-            <a:srgbClr val="FFFFFF"/>
-          </a:solidFill>
-          <a:ln w="12700">
-            <a:solidFill>
-              <a:srgbClr val="9ACD4C"/>
-            </a:solidFill>
-          </a:ln>
-        </p:spPr>
-        <p:txBody>
-          <a:bodyPr/>
-          <a:lstStyle/>
-          <a:p>
-            <a:endParaRPr lang="en-US"/>
-          </a:p>
-        </p:txBody>
-      </p:sp>
-      <p:sp>
-        <p:nvSpPr>
-          <p:cNvPr id="20" name="Right card"/>
-          <p:cNvSpPr/>
-          <p:nvPr/>
-        </p:nvSpPr>
-        <p:spPr>
-          <a:xfrm>
-            <a:off x="6205000" y="1200000"/>
-            <a:ext cx="4845588" cy="4400000"/>
-          </a:xfrm>
-          <a:prstGeom prst="roundRect">
-            <a:avLst>
-              <a:gd name="adj" fmla="val 3000"/>
-            </a:avLst>
-          </a:prstGeom>
-          <a:solidFill>
-            <a:srgbClr val="FFFFFF"/>
-          </a:solidFill>
-          <a:ln w="12700">
-            <a:solidFill>
-              <a:srgbClr val="9ACD4C"/>
-            </a:solidFill>
-          </a:ln>
-        </p:spPr>
-        <p:txBody>
-          <a:bodyPr/>
-          <a:lstStyle/>
-          <a:p>
-            <a:endParaRPr lang="en-US"/>
-          </a:p>
-        </p:txBody>
-      </p:sp>
-      <p:sp>
-        <p:nvSpPr>
-          <p:cNvPr id="11" name="Left heading"/>
-          <p:cNvSpPr/>
-          <p:nvPr/>
-        </p:nvSpPr>
-        <p:spPr>
-          <a:xfrm>
-            <a:off x="1311412" y="1300000"/>
-            <a:ext cx="4505588" cy="430000"/>
+            <a:off x="1143000" y="621792"/>
+            <a:ext cx="4069080" cy="347472"/>
           </a:xfrm>
           <a:prstGeom prst="rect">
             <a:avLst/>
@@ -10368,65 +10092,38 @@
           <a:noFill/>
         </p:spPr>
         <p:txBody>
-          <a:bodyPr wrap="square" lIns="0" tIns="0" rIns="0" bIns="0" anchor="t"/>
-          <a:lstStyle/>
-          <a:p>
-            <a:pPr algn="l"/>
-            <a:r>
-              <a:rPr lang="en-US" sz="1900" b="1">
-                <a:solidFill>
-                  <a:srgbClr val="0F766E"/>
-                </a:solidFill>
-                <a:latin typeface="+mn-lt"/>
+          <a:bodyPr wrap="square" lIns="0" tIns="0" rIns="0" bIns="0" anchor="t">
+            <a:spAutoFit/>
+          </a:bodyPr>
+          <a:lstStyle/>
+          <a:p>
+            <a:pPr algn="l">
+              <a:lnSpc>
+                <a:spcPct val="100000"/>
+              </a:lnSpc>
+            </a:pPr>
+            <a:r>
+              <a:rPr sz="1800" b="1" u="none">
+                <a:solidFill>
+                  <a:srgbClr val="9ACD4C"/>
+                </a:solidFill>
+                <a:latin typeface="+mj-lt"/>
               </a:rPr>
-              <a:t>Conclusions</a:t>
-            </a:r>
-          </a:p>
-        </p:txBody>
-      </p:sp>
-      <p:sp>
-        <p:nvSpPr>
-          <p:cNvPr id="21" name="Right heading"/>
+              <a:t>THANK YOU</a:t>
+            </a:r>
+          </a:p>
+        </p:txBody>
+      </p:sp>
+      <p:sp>
+        <p:nvSpPr>
+          <p:cNvPr id="3" name="Closing accent rule"/>
           <p:cNvSpPr/>
           <p:nvPr/>
         </p:nvSpPr>
         <p:spPr>
           <a:xfrm>
-            <a:off x="6375000" y="1300000"/>
-            <a:ext cx="4505588" cy="430000"/>
-          </a:xfrm>
-          <a:prstGeom prst="rect">
-            <a:avLst/>
-          </a:prstGeom>
-          <a:noFill/>
-        </p:spPr>
-        <p:txBody>
-          <a:bodyPr wrap="square" lIns="0" tIns="0" rIns="0" bIns="0" anchor="t"/>
-          <a:lstStyle/>
-          <a:p>
-            <a:pPr algn="l"/>
-            <a:r>
-              <a:rPr lang="en-US" sz="1900" b="1">
-                <a:solidFill>
-                  <a:srgbClr val="0F766E"/>
-                </a:solidFill>
-                <a:latin typeface="+mn-lt"/>
-              </a:rPr>
-              <a:t>Future Work</a:t>
-            </a:r>
-          </a:p>
-        </p:txBody>
-      </p:sp>
-      <p:sp>
-        <p:nvSpPr>
-          <p:cNvPr id="12" name="Left rule"/>
-          <p:cNvSpPr/>
-          <p:nvPr/>
-        </p:nvSpPr>
-        <p:spPr>
-          <a:xfrm>
-            <a:off x="1311412" y="1790000"/>
-            <a:ext cx="4505588" cy="20000"/>
+            <a:off x="1143000" y="1024128"/>
+            <a:ext cx="658368" cy="41148"/>
           </a:xfrm>
           <a:prstGeom prst="rect">
             <a:avLst/>
@@ -10434,25 +10131,121 @@
           <a:solidFill>
             <a:srgbClr val="9ACD4C"/>
           </a:solidFill>
-        </p:spPr>
-        <p:txBody>
-          <a:bodyPr/>
-          <a:lstStyle/>
-          <a:p>
-            <a:endParaRPr lang="en-US"/>
-          </a:p>
-        </p:txBody>
-      </p:sp>
-      <p:sp>
-        <p:nvSpPr>
-          <p:cNvPr id="22" name="Right rule"/>
+          <a:ln>
+            <a:noFill/>
+          </a:ln>
+        </p:spPr>
+        <p:style>
+          <a:lnRef idx="1">
+            <a:schemeClr val="accent1"/>
+          </a:lnRef>
+          <a:fillRef idx="3">
+            <a:schemeClr val="accent1"/>
+          </a:fillRef>
+          <a:effectRef idx="2">
+            <a:schemeClr val="accent1"/>
+          </a:effectRef>
+          <a:fontRef idx="minor">
+            <a:schemeClr val="lt1"/>
+          </a:fontRef>
+        </p:style>
+        <p:txBody>
+          <a:bodyPr rtlCol="0" anchor="ctr"/>
+          <a:lstStyle/>
+          <a:p>
+            <a:pPr algn="ctr"/>
+            <a:endParaRPr/>
+          </a:p>
+        </p:txBody>
+      </p:sp>
+      <p:sp>
+        <p:nvSpPr>
+          <p:cNvPr id="4" name="Questions title"/>
+          <p:cNvSpPr txBox="1"/>
+          <p:nvPr/>
+        </p:nvSpPr>
+        <p:spPr>
+          <a:xfrm>
+            <a:off x="1143000" y="1353312"/>
+            <a:ext cx="4251960" cy="960120"/>
+          </a:xfrm>
+          <a:prstGeom prst="rect">
+            <a:avLst/>
+          </a:prstGeom>
+          <a:noFill/>
+        </p:spPr>
+        <p:txBody>
+          <a:bodyPr wrap="square" lIns="0" tIns="0" rIns="0" bIns="0" anchor="t">
+            <a:spAutoFit/>
+          </a:bodyPr>
+          <a:lstStyle/>
+          <a:p>
+            <a:pPr algn="l">
+              <a:lnSpc>
+                <a:spcPct val="100000"/>
+              </a:lnSpc>
+            </a:pPr>
+            <a:r>
+              <a:rPr sz="5000" b="1" u="none">
+                <a:solidFill>
+                  <a:srgbClr val="FFFFFF"/>
+                </a:solidFill>
+                <a:latin typeface="+mj-lt"/>
+              </a:rPr>
+              <a:t>Questions?</a:t>
+            </a:r>
+          </a:p>
+        </p:txBody>
+      </p:sp>
+      <p:sp>
+        <p:nvSpPr>
+          <p:cNvPr id="5" name="Closing subline"/>
+          <p:cNvSpPr txBox="1"/>
+          <p:nvPr/>
+        </p:nvSpPr>
+        <p:spPr>
+          <a:xfrm>
+            <a:off x="1143000" y="2395728"/>
+            <a:ext cx="4069080" cy="841248"/>
+          </a:xfrm>
+          <a:prstGeom prst="rect">
+            <a:avLst/>
+          </a:prstGeom>
+          <a:noFill/>
+        </p:spPr>
+        <p:txBody>
+          <a:bodyPr wrap="square" lIns="0" tIns="0" rIns="0" bIns="0" anchor="t">
+            <a:spAutoFit/>
+          </a:bodyPr>
+          <a:lstStyle/>
+          <a:p>
+            <a:pPr algn="l">
+              <a:lnSpc>
+                <a:spcPct val="110000"/>
+              </a:lnSpc>
+            </a:pPr>
+            <a:r>
+              <a:rPr sz="1800" b="0" u="none">
+                <a:solidFill>
+                  <a:srgbClr val="E2F0D9"/>
+                </a:solidFill>
+                <a:latin typeface="+mn-lt"/>
+              </a:rPr>
+              <a:t>Explore the code, launch the dashboard, or continue the conversation.</a:t>
+            </a:r>
+          </a:p>
+        </p:txBody>
+      </p:sp>
+      <p:sp>
+        <p:nvSpPr>
+          <p:cNvPr id="6" name="Resource divider"/>
           <p:cNvSpPr/>
           <p:nvPr/>
         </p:nvSpPr>
         <p:spPr>
           <a:xfrm>
-            <a:off x="6375000" y="1790000"/>
-            <a:ext cx="4505588" cy="20000"/>
+            <a:off x="5504688" y="713232"/>
+            <a:ext cx="22860" cy="5413248"/>
           </a:xfrm>
           <a:prstGeom prst="rect">
             <a:avLst/>
@@ -10460,25 +10253,43 @@
           <a:solidFill>
             <a:srgbClr val="9ACD4C"/>
           </a:solidFill>
-        </p:spPr>
-        <p:txBody>
-          <a:bodyPr/>
-          <a:lstStyle/>
-          <a:p>
-            <a:endParaRPr lang="en-US"/>
-          </a:p>
-        </p:txBody>
-      </p:sp>
-      <p:sp>
-        <p:nvSpPr>
-          <p:cNvPr id="50" name="Conclusions list"/>
-          <p:cNvSpPr/>
+          <a:ln>
+            <a:noFill/>
+          </a:ln>
+        </p:spPr>
+        <p:style>
+          <a:lnRef idx="1">
+            <a:schemeClr val="accent1"/>
+          </a:lnRef>
+          <a:fillRef idx="3">
+            <a:schemeClr val="accent1"/>
+          </a:fillRef>
+          <a:effectRef idx="2">
+            <a:schemeClr val="accent1"/>
+          </a:effectRef>
+          <a:fontRef idx="minor">
+            <a:schemeClr val="lt1"/>
+          </a:fontRef>
+        </p:style>
+        <p:txBody>
+          <a:bodyPr rtlCol="0" anchor="ctr"/>
+          <a:lstStyle/>
+          <a:p>
+            <a:pPr algn="ctr"/>
+            <a:endParaRPr/>
+          </a:p>
+        </p:txBody>
+      </p:sp>
+      <p:sp>
+        <p:nvSpPr>
+          <p:cNvPr id="7" name="Resources heading"/>
+          <p:cNvSpPr txBox="1"/>
           <p:nvPr/>
         </p:nvSpPr>
         <p:spPr>
           <a:xfrm>
-            <a:off x="1311412" y="2010000"/>
-            <a:ext cx="4505588" cy="3480000"/>
+            <a:off x="5925312" y="640080"/>
+            <a:ext cx="5047488" cy="384048"/>
           </a:xfrm>
           <a:prstGeom prst="rect">
             <a:avLst/>
@@ -10486,101 +10297,38 @@
           <a:noFill/>
         </p:spPr>
         <p:txBody>
-          <a:bodyPr wrap="square" lIns="0" tIns="0" rIns="0" bIns="0" anchor="t"/>
-          <a:lstStyle/>
-          <a:p>
-            <a:pPr marL="342900" indent="-342900">
-              <a:spcAft>
-                <a:spcPts val="1000"/>
-              </a:spcAft>
-              <a:buClr>
-                <a:srgbClr val="9ACD4C"/>
-              </a:buClr>
-              <a:buFont typeface="Arial"/>
-              <a:buChar char="✓"/>
+          <a:bodyPr wrap="square" lIns="0" tIns="0" rIns="0" bIns="0" anchor="t">
+            <a:spAutoFit/>
+          </a:bodyPr>
+          <a:lstStyle/>
+          <a:p>
+            <a:pPr algn="l">
+              <a:lnSpc>
+                <a:spcPct val="100000"/>
+              </a:lnSpc>
             </a:pPr>
             <a:r>
-              <a:rPr lang="en-US" sz="1250">
-                <a:solidFill>
-                  <a:srgbClr val="0B2138"/>
-                </a:solidFill>
-                <a:latin typeface="+mn-lt"/>
+              <a:rPr sz="1800" b="1" u="none">
+                <a:solidFill>
+                  <a:srgbClr val="9ACD4C"/>
+                </a:solidFill>
+                <a:latin typeface="+mj-lt"/>
               </a:rPr>
-              <a:t>Integrated multiple public datasets into a unified analytical dataset</a:t>
-            </a:r>
-          </a:p>
-          <a:p>
-            <a:pPr marL="342900" indent="-342900">
-              <a:spcAft>
-                <a:spcPts val="1000"/>
-              </a:spcAft>
-              <a:buClr>
-                <a:srgbClr val="9ACD4C"/>
-              </a:buClr>
-              <a:buFont typeface="Arial"/>
-              <a:buChar char="✓"/>
-            </a:pPr>
-            <a:r>
-              <a:rPr lang="en-US" sz="1250">
-                <a:solidFill>
-                  <a:srgbClr val="0B2138"/>
-                </a:solidFill>
-                <a:latin typeface="+mn-lt"/>
-              </a:rPr>
-              <a:t>Developed an accurate Random Forest model for COVID-19 mortality prediction</a:t>
-            </a:r>
-          </a:p>
-          <a:p>
-            <a:pPr marL="342900" indent="-342900">
-              <a:spcAft>
-                <a:spcPts val="1000"/>
-              </a:spcAft>
-              <a:buClr>
-                <a:srgbClr val="9ACD4C"/>
-              </a:buClr>
-              <a:buFont typeface="Arial"/>
-              <a:buChar char="✓"/>
-            </a:pPr>
-            <a:r>
-              <a:rPr lang="en-US" sz="1250">
-                <a:solidFill>
-                  <a:srgbClr val="0B2138"/>
-                </a:solidFill>
-                <a:latin typeface="+mn-lt"/>
-              </a:rPr>
-              <a:t>Applied SHAP to provide transparent global and local model explanations</a:t>
-            </a:r>
-          </a:p>
-          <a:p>
-            <a:pPr marL="342900" indent="-342900">
-              <a:buClr>
-                <a:srgbClr val="9ACD4C"/>
-              </a:buClr>
-              <a:buFont typeface="Arial"/>
-              <a:buChar char="✓"/>
-            </a:pPr>
-            <a:r>
-              <a:rPr lang="en-US" sz="1250">
-                <a:solidFill>
-                  <a:srgbClr val="0B2138"/>
-                </a:solidFill>
-                <a:latin typeface="+mn-lt"/>
-              </a:rPr>
-              <a:t>Built an interactive decision-support dashboard for country-level analysis</a:t>
-            </a:r>
-          </a:p>
-        </p:txBody>
-      </p:sp>
-      <p:sp>
-        <p:nvSpPr>
-          <p:cNvPr id="80" name="Future Work list"/>
-          <p:cNvSpPr/>
+              <a:t>RESOURCES</a:t>
+            </a:r>
+          </a:p>
+        </p:txBody>
+      </p:sp>
+      <p:sp>
+        <p:nvSpPr>
+          <p:cNvPr id="8" name="GitHub label"/>
+          <p:cNvSpPr txBox="1"/>
           <p:nvPr/>
         </p:nvSpPr>
         <p:spPr>
           <a:xfrm>
-            <a:off x="6375000" y="2010000"/>
-            <a:ext cx="4505588" cy="3480000"/>
+            <a:off x="5925312" y="1298448"/>
+            <a:ext cx="5047488" cy="329184"/>
           </a:xfrm>
           <a:prstGeom prst="rect">
             <a:avLst/>
@@ -10588,148 +10336,392 @@
           <a:noFill/>
         </p:spPr>
         <p:txBody>
-          <a:bodyPr wrap="square" lIns="0" tIns="0" rIns="0" bIns="0" anchor="t"/>
-          <a:lstStyle/>
-          <a:p>
-            <a:pPr marL="285750" indent="-285750">
-              <a:spcAft>
-                <a:spcPts val="1200"/>
-              </a:spcAft>
-              <a:buClr>
-                <a:srgbClr val="9ACD4C"/>
-              </a:buClr>
-              <a:buFont typeface="Arial"/>
-              <a:buChar char="•"/>
+          <a:bodyPr wrap="square" lIns="0" tIns="0" rIns="0" bIns="0" anchor="t">
+            <a:spAutoFit/>
+          </a:bodyPr>
+          <a:lstStyle/>
+          <a:p>
+            <a:pPr algn="l">
+              <a:lnSpc>
+                <a:spcPct val="100000"/>
+              </a:lnSpc>
             </a:pPr>
             <a:r>
-              <a:rPr lang="en-US" sz="1300">
-                <a:solidFill>
-                  <a:srgbClr val="0B2138"/>
+              <a:rPr sz="1700" b="1" u="none">
+                <a:solidFill>
+                  <a:srgbClr val="FFFFFF"/>
                 </a:solidFill>
                 <a:latin typeface="+mn-lt"/>
               </a:rPr>
-              <a:t>Update with newer COVID-19 datasets</a:t>
-            </a:r>
-          </a:p>
-          <a:p>
-            <a:pPr marL="285750" indent="-285750">
-              <a:spcAft>
-                <a:spcPts val="1200"/>
-              </a:spcAft>
-              <a:buClr>
-                <a:srgbClr val="9ACD4C"/>
-              </a:buClr>
-              <a:buFont typeface="Arial"/>
-              <a:buChar char="•"/>
+              <a:t>GitHub Repository</a:t>
+            </a:r>
+          </a:p>
+        </p:txBody>
+      </p:sp>
+      <p:sp>
+        <p:nvSpPr>
+          <p:cNvPr id="9" name="GitHub URL"/>
+          <p:cNvSpPr txBox="1"/>
+          <p:nvPr/>
+        </p:nvSpPr>
+        <p:spPr>
+          <a:xfrm>
+            <a:off x="5925312" y="1664208"/>
+            <a:ext cx="5047488" cy="384721"/>
+          </a:xfrm>
+          <a:prstGeom prst="rect">
+            <a:avLst/>
+          </a:prstGeom>
+          <a:noFill/>
+        </p:spPr>
+        <p:txBody>
+          <a:bodyPr wrap="square" lIns="0" tIns="0" rIns="0" bIns="0" anchor="t">
+            <a:spAutoFit/>
+          </a:bodyPr>
+          <a:lstStyle/>
+          <a:p>
+            <a:pPr algn="l">
+              <a:lnSpc>
+                <a:spcPct val="100000"/>
+              </a:lnSpc>
             </a:pPr>
             <a:r>
-              <a:rPr lang="en-US" sz="1300">
-                <a:solidFill>
-                  <a:srgbClr val="0B2138"/>
+              <a:rPr sz="1250" b="0" u="sng" dirty="0">
+                <a:solidFill>
+                  <a:srgbClr val="E2F0D9"/>
+                </a:solidFill>
+                <a:latin typeface="+mn-lt"/>
+                <a:hlinkClick r:id="rId3"/>
+              </a:rPr>
+              <a:t>https://</a:t>
+            </a:r>
+            <a:r>
+              <a:rPr sz="1250" b="0" u="sng" dirty="0" err="1">
+                <a:solidFill>
+                  <a:srgbClr val="E2F0D9"/>
+                </a:solidFill>
+                <a:latin typeface="+mn-lt"/>
+                <a:hlinkClick r:id="rId3"/>
+              </a:rPr>
+              <a:t>github.com</a:t>
+            </a:r>
+            <a:r>
+              <a:rPr sz="1250" b="0" u="sng" dirty="0">
+                <a:solidFill>
+                  <a:srgbClr val="E2F0D9"/>
+                </a:solidFill>
+                <a:latin typeface="+mn-lt"/>
+                <a:hlinkClick r:id="rId3"/>
+              </a:rPr>
+              <a:t>/darylm910/</a:t>
+            </a:r>
+            <a:r>
+              <a:rPr sz="1250" b="0" u="sng" dirty="0" err="1">
+                <a:solidFill>
+                  <a:srgbClr val="E2F0D9"/>
+                </a:solidFill>
+                <a:latin typeface="+mn-lt"/>
+                <a:hlinkClick r:id="rId3"/>
+              </a:rPr>
+              <a:t>COVID_Decision_Support_System</a:t>
+            </a:r>
+            <a:endParaRPr sz="1250" b="0" u="sng" dirty="0">
+              <a:solidFill>
+                <a:srgbClr val="E2F0D9"/>
+              </a:solidFill>
+              <a:latin typeface="+mn-lt"/>
+            </a:endParaRPr>
+          </a:p>
+        </p:txBody>
+      </p:sp>
+      <p:sp>
+        <p:nvSpPr>
+          <p:cNvPr id="10" name="Dashboard label"/>
+          <p:cNvSpPr txBox="1">
+            <a:spLocks/>
+          </p:cNvSpPr>
+          <p:nvPr/>
+        </p:nvSpPr>
+        <p:spPr>
+          <a:xfrm>
+            <a:off x="5925312" y="2423160"/>
+            <a:ext cx="5047488" cy="329184"/>
+          </a:xfrm>
+          <a:prstGeom prst="rect">
+            <a:avLst/>
+          </a:prstGeom>
+          <a:noFill/>
+        </p:spPr>
+        <p:txBody>
+          <a:bodyPr wrap="square" lIns="0" tIns="0" rIns="0" bIns="0" anchor="t">
+            <a:spAutoFit/>
+          </a:bodyPr>
+          <a:lstStyle/>
+          <a:p>
+            <a:pPr algn="l">
+              <a:lnSpc>
+                <a:spcPct val="100000"/>
+              </a:lnSpc>
+            </a:pPr>
+            <a:r>
+              <a:rPr lang="en-US" sz="1700" b="1" u="none">
+                <a:solidFill>
+                  <a:srgbClr val="FFFFFF"/>
                 </a:solidFill>
                 <a:latin typeface="+mn-lt"/>
               </a:rPr>
-              <a:t>Extend the framework to temporal forecasting</a:t>
-            </a:r>
-          </a:p>
-          <a:p>
-            <a:pPr marL="285750" indent="-285750">
-              <a:spcAft>
-                <a:spcPts val="1200"/>
-              </a:spcAft>
-              <a:buClr>
-                <a:srgbClr val="9ACD4C"/>
-              </a:buClr>
-              <a:buFont typeface="Arial"/>
-              <a:buChar char="•"/>
+              <a:t>Live Dashboard</a:t>
+            </a:r>
+          </a:p>
+        </p:txBody>
+      </p:sp>
+      <p:sp>
+        <p:nvSpPr>
+          <p:cNvPr id="11" name="Dashboard URL"/>
+          <p:cNvSpPr txBox="1">
+            <a:spLocks/>
+          </p:cNvSpPr>
+          <p:nvPr/>
+        </p:nvSpPr>
+        <p:spPr>
+          <a:xfrm>
+            <a:off x="5925312" y="2788920"/>
+            <a:ext cx="5047488" cy="369332"/>
+          </a:xfrm>
+          <a:prstGeom prst="rect">
+            <a:avLst/>
+          </a:prstGeom>
+          <a:noFill/>
+        </p:spPr>
+        <p:txBody>
+          <a:bodyPr wrap="square" lIns="0" tIns="0" rIns="0" bIns="0" anchor="t">
+            <a:spAutoFit/>
+          </a:bodyPr>
+          <a:lstStyle/>
+          <a:p>
+            <a:pPr algn="l">
+              <a:lnSpc>
+                <a:spcPct val="100000"/>
+              </a:lnSpc>
             </a:pPr>
             <a:r>
-              <a:rPr lang="en-US" sz="1300">
-                <a:solidFill>
-                  <a:srgbClr val="0B2138"/>
+              <a:rPr lang="en-US" sz="1200" b="0" u="sng" dirty="0">
+                <a:solidFill>
+                  <a:srgbClr val="E2F0D9"/>
+                </a:solidFill>
+                <a:latin typeface="+mn-lt"/>
+                <a:hlinkClick r:id="rId4"/>
+              </a:rPr>
+              <a:t>https://coviddecisionsupportsystem-bwdacuubwqgfphchtpbb8p.streamlit.app</a:t>
+            </a:r>
+            <a:endParaRPr lang="en-US" sz="1200" b="0" u="sng" dirty="0">
+              <a:solidFill>
+                <a:srgbClr val="E2F0D9"/>
+              </a:solidFill>
+              <a:latin typeface="+mn-lt"/>
+            </a:endParaRPr>
+          </a:p>
+        </p:txBody>
+      </p:sp>
+      <p:sp>
+        <p:nvSpPr>
+          <p:cNvPr id="12" name="Technologies label"/>
+          <p:cNvSpPr txBox="1">
+            <a:spLocks/>
+          </p:cNvSpPr>
+          <p:nvPr/>
+        </p:nvSpPr>
+        <p:spPr>
+          <a:xfrm>
+            <a:off x="5925312" y="3703320"/>
+            <a:ext cx="5047488" cy="329184"/>
+          </a:xfrm>
+          <a:prstGeom prst="rect">
+            <a:avLst/>
+          </a:prstGeom>
+          <a:noFill/>
+        </p:spPr>
+        <p:txBody>
+          <a:bodyPr wrap="square" lIns="0" tIns="0" rIns="0" bIns="0" anchor="t">
+            <a:spAutoFit/>
+          </a:bodyPr>
+          <a:lstStyle/>
+          <a:p>
+            <a:pPr algn="l">
+              <a:lnSpc>
+                <a:spcPct val="100000"/>
+              </a:lnSpc>
+            </a:pPr>
+            <a:r>
+              <a:rPr lang="en-US" sz="1700" b="1" u="none">
+                <a:solidFill>
+                  <a:srgbClr val="FFFFFF"/>
                 </a:solidFill>
                 <a:latin typeface="+mn-lt"/>
               </a:rPr>
-              <a:t>Evaluate additional machine learning models</a:t>
-            </a:r>
-          </a:p>
-          <a:p>
-            <a:pPr marL="285750" indent="-285750">
-              <a:buClr>
-                <a:srgbClr val="9ACD4C"/>
-              </a:buClr>
-              <a:buFont typeface="Arial"/>
-              <a:buChar char="•"/>
+              <a:t>Technologies</a:t>
+            </a:r>
+          </a:p>
+        </p:txBody>
+      </p:sp>
+      <p:sp>
+        <p:nvSpPr>
+          <p:cNvPr id="13" name="Technologies list"/>
+          <p:cNvSpPr txBox="1"/>
+          <p:nvPr/>
+        </p:nvSpPr>
+        <p:spPr>
+          <a:xfrm>
+            <a:off x="5925312" y="4087368"/>
+            <a:ext cx="5047488" cy="868680"/>
+          </a:xfrm>
+          <a:prstGeom prst="rect">
+            <a:avLst/>
+          </a:prstGeom>
+          <a:noFill/>
+        </p:spPr>
+        <p:txBody>
+          <a:bodyPr wrap="square" lIns="0" tIns="0" rIns="0" bIns="0" anchor="t">
+            <a:spAutoFit/>
+          </a:bodyPr>
+          <a:lstStyle/>
+          <a:p>
+            <a:pPr algn="l">
+              <a:lnSpc>
+                <a:spcPct val="110000"/>
+              </a:lnSpc>
             </a:pPr>
             <a:r>
-              <a:rPr lang="en-US" sz="1300">
-                <a:solidFill>
-                  <a:srgbClr val="0B2138"/>
+              <a:rPr sz="1450" b="0" u="none">
+                <a:solidFill>
+                  <a:srgbClr val="E2F0D9"/>
                 </a:solidFill>
                 <a:latin typeface="+mn-lt"/>
               </a:rPr>
-              <a:t>Deploy the dashboard as a public web application</a:t>
-            </a:r>
-          </a:p>
-        </p:txBody>
-      </p:sp>
-      <p:sp>
-        <p:nvSpPr>
-          <p:cNvPr id="90" name="Final Takeaway"/>
+              <a:t>Python  •  Pandas  •  Scikit-learn
+SHAP  •  Streamlit  •  Plotly</a:t>
+            </a:r>
+          </a:p>
+        </p:txBody>
+      </p:sp>
+      <p:sp>
+        <p:nvSpPr>
+          <p:cNvPr id="14" name="Footer rule"/>
           <p:cNvSpPr/>
           <p:nvPr/>
         </p:nvSpPr>
         <p:spPr>
           <a:xfrm>
-            <a:off x="1141412" y="5700000"/>
-            <a:ext cx="9909176" cy="1050000"/>
-          </a:xfrm>
-          <a:prstGeom prst="roundRect">
-            <a:avLst>
-              <a:gd name="adj" fmla="val 6000"/>
-            </a:avLst>
+            <a:off x="5925312" y="5266944"/>
+            <a:ext cx="5047488" cy="16459"/>
+          </a:xfrm>
+          <a:prstGeom prst="rect">
+            <a:avLst/>
           </a:prstGeom>
           <a:solidFill>
-            <a:srgbClr val="E2F0D9"/>
+            <a:srgbClr val="7B8E8A"/>
           </a:solidFill>
-          <a:ln w="19050">
-            <a:solidFill>
-              <a:srgbClr val="9ACD4C"/>
-            </a:solidFill>
+          <a:ln>
+            <a:noFill/>
           </a:ln>
         </p:spPr>
-        <p:txBody>
-          <a:bodyPr wrap="square" lIns="182880" tIns="50000" rIns="182880" bIns="50000" anchor="ctr"/>
-          <a:lstStyle/>
-          <a:p>
-            <a:pPr algn="ctr">
-              <a:spcAft>
-                <a:spcPts val="300"/>
-              </a:spcAft>
+        <p:style>
+          <a:lnRef idx="1">
+            <a:schemeClr val="accent1"/>
+          </a:lnRef>
+          <a:fillRef idx="3">
+            <a:schemeClr val="accent1"/>
+          </a:fillRef>
+          <a:effectRef idx="2">
+            <a:schemeClr val="accent1"/>
+          </a:effectRef>
+          <a:fontRef idx="minor">
+            <a:schemeClr val="lt1"/>
+          </a:fontRef>
+        </p:style>
+        <p:txBody>
+          <a:bodyPr rtlCol="0" anchor="ctr"/>
+          <a:lstStyle/>
+          <a:p>
+            <a:pPr algn="ctr"/>
+            <a:endParaRPr/>
+          </a:p>
+        </p:txBody>
+      </p:sp>
+      <p:sp>
+        <p:nvSpPr>
+          <p:cNvPr id="15" name="Program footer"/>
+          <p:cNvSpPr txBox="1"/>
+          <p:nvPr/>
+        </p:nvSpPr>
+        <p:spPr>
+          <a:xfrm>
+            <a:off x="5925312" y="5449824"/>
+            <a:ext cx="5047488" cy="329184"/>
+          </a:xfrm>
+          <a:prstGeom prst="rect">
+            <a:avLst/>
+          </a:prstGeom>
+          <a:noFill/>
+        </p:spPr>
+        <p:txBody>
+          <a:bodyPr wrap="square" lIns="0" tIns="0" rIns="0" bIns="0" anchor="t">
+            <a:spAutoFit/>
+          </a:bodyPr>
+          <a:lstStyle/>
+          <a:p>
+            <a:pPr algn="l">
+              <a:lnSpc>
+                <a:spcPct val="100000"/>
+              </a:lnSpc>
             </a:pPr>
             <a:r>
-              <a:rPr lang="en-US" sz="1400" b="1">
-                <a:solidFill>
-                  <a:srgbClr val="385723"/>
-                </a:solidFill>
-              </a:rPr>
-              <a:t>Final Takeaway</a:t>
-            </a:r>
-          </a:p>
-          <a:p>
-            <a:pPr algn="ctr">
-              <a:spcAft>
-                <a:spcPts val="300"/>
-              </a:spcAft>
-            </a:pPr>
-            <a:r>
-              <a:rPr lang="en-US" sz="1250">
-                <a:solidFill>
-                  <a:srgbClr val="0B2138"/>
+              <a:rPr sz="1350" b="0" u="none">
+                <a:solidFill>
+                  <a:srgbClr val="C8D5D2"/>
                 </a:solidFill>
                 <a:latin typeface="+mn-lt"/>
               </a:rPr>
-              <a:t>This project demonstrates that integrating machine learning, explainable AI, and interactive visualization can create practical decision-support tools for understanding complex public health outcomes.</a:t>
+              <a:t>Springboard Data Science Career Track</a:t>
+            </a:r>
+          </a:p>
+        </p:txBody>
+      </p:sp>
+      <p:sp>
+        <p:nvSpPr>
+          <p:cNvPr id="16" name="Capstone footer"/>
+          <p:cNvSpPr txBox="1"/>
+          <p:nvPr/>
+        </p:nvSpPr>
+        <p:spPr>
+          <a:xfrm>
+            <a:off x="5925312" y="5779008"/>
+            <a:ext cx="5047488" cy="310896"/>
+          </a:xfrm>
+          <a:prstGeom prst="rect">
+            <a:avLst/>
+          </a:prstGeom>
+          <a:noFill/>
+        </p:spPr>
+        <p:txBody>
+          <a:bodyPr wrap="square" lIns="0" tIns="0" rIns="0" bIns="0" anchor="t">
+            <a:spAutoFit/>
+          </a:bodyPr>
+          <a:lstStyle/>
+          <a:p>
+            <a:pPr algn="l">
+              <a:lnSpc>
+                <a:spcPct val="100000"/>
+              </a:lnSpc>
+            </a:pPr>
+            <a:r>
+              <a:rPr sz="1350" b="1" u="none">
+                <a:solidFill>
+                  <a:srgbClr val="9ACD4C"/>
+                </a:solidFill>
+                <a:latin typeface="+mn-lt"/>
+              </a:rPr>
+              <a:t>Capstone 3</a:t>
             </a:r>
           </a:p>
         </p:txBody>
@@ -10994,9 +10986,9 @@
 </file>
 
 <file path=ppt/theme/theme2.xml><?xml version="1.0" encoding="utf-8"?>
-<a:theme xmlns:a="http://schemas.openxmlformats.org/drawingml/2006/main" name="Circuit">
+<a:theme xmlns:a="http://schemas.openxmlformats.org/drawingml/2006/main" name="Office Theme">
   <a:themeElements>
-    <a:clrScheme name="Circuit">
+    <a:clrScheme name="Office">
       <a:dk1>
         <a:sysClr val="windowText" lastClr="000000"/>
       </a:dk1>
@@ -11004,44 +10996,44 @@
         <a:sysClr val="window" lastClr="FFFFFF"/>
       </a:lt1>
       <a:dk2>
-        <a:srgbClr val="134770"/>
+        <a:srgbClr val="0E2841"/>
       </a:dk2>
       <a:lt2>
-        <a:srgbClr val="82FFFF"/>
+        <a:srgbClr val="E8E8E8"/>
       </a:lt2>
       <a:accent1>
-        <a:srgbClr val="9ACD4C"/>
+        <a:srgbClr val="156082"/>
       </a:accent1>
       <a:accent2>
-        <a:srgbClr val="FAA93A"/>
+        <a:srgbClr val="E97132"/>
       </a:accent2>
       <a:accent3>
-        <a:srgbClr val="D35940"/>
+        <a:srgbClr val="196B24"/>
       </a:accent3>
       <a:accent4>
-        <a:srgbClr val="B258D3"/>
+        <a:srgbClr val="0F9ED5"/>
       </a:accent4>
       <a:accent5>
-        <a:srgbClr val="63A0CC"/>
+        <a:srgbClr val="A02B93"/>
       </a:accent5>
       <a:accent6>
-        <a:srgbClr val="8AC4A7"/>
+        <a:srgbClr val="4EA72E"/>
       </a:accent6>
       <a:hlink>
-        <a:srgbClr val="B8FA56"/>
+        <a:srgbClr val="467886"/>
       </a:hlink>
       <a:folHlink>
-        <a:srgbClr val="7AF8CC"/>
+        <a:srgbClr val="96607D"/>
       </a:folHlink>
     </a:clrScheme>
-    <a:fontScheme name="Circuit">
+    <a:fontScheme name="Office">
       <a:majorFont>
-        <a:latin typeface="Tw Cen MT" panose="020B0602020104020603"/>
+        <a:latin typeface="Aptos Display" panose="02110004020202020204"/>
         <a:ea typeface=""/>
         <a:cs typeface=""/>
-        <a:font script="Jpan" typeface="ＭＳ Ｐゴシック"/>
+        <a:font script="Jpan" typeface="游ゴシック Light"/>
         <a:font script="Hang" typeface="맑은 고딕"/>
-        <a:font script="Hans" typeface="宋体"/>
+        <a:font script="Hans" typeface="等线 Light"/>
         <a:font script="Hant" typeface="新細明體"/>
         <a:font script="Arab" typeface="Times New Roman"/>
         <a:font script="Hebr" typeface="Times New Roman"/>
@@ -11069,14 +11061,31 @@
         <a:font script="Viet" typeface="Times New Roman"/>
         <a:font script="Uigh" typeface="Microsoft Uighur"/>
         <a:font script="Geor" typeface="Sylfaen"/>
+        <a:font script="Armn" typeface="Arial"/>
+        <a:font script="Bugi" typeface="Leelawadee UI"/>
+        <a:font script="Bopo" typeface="Microsoft JhengHei"/>
+        <a:font script="Java" typeface="Javanese Text"/>
+        <a:font script="Lisu" typeface="Segoe UI"/>
+        <a:font script="Mymr" typeface="Myanmar Text"/>
+        <a:font script="Nkoo" typeface="Ebrima"/>
+        <a:font script="Olck" typeface="Nirmala UI"/>
+        <a:font script="Osma" typeface="Ebrima"/>
+        <a:font script="Phag" typeface="Phagspa"/>
+        <a:font script="Syrn" typeface="Estrangelo Edessa"/>
+        <a:font script="Syrj" typeface="Estrangelo Edessa"/>
+        <a:font script="Syre" typeface="Estrangelo Edessa"/>
+        <a:font script="Sora" typeface="Nirmala UI"/>
+        <a:font script="Tale" typeface="Microsoft Tai Le"/>
+        <a:font script="Talu" typeface="Microsoft New Tai Lue"/>
+        <a:font script="Tfng" typeface="Ebrima"/>
       </a:majorFont>
       <a:minorFont>
-        <a:latin typeface="Tw Cen MT" panose="020B0602020104020603"/>
+        <a:latin typeface="Aptos" panose="02110004020202020204"/>
         <a:ea typeface=""/>
         <a:cs typeface=""/>
-        <a:font script="Jpan" typeface="ＭＳ Ｐゴシック"/>
+        <a:font script="Jpan" typeface="游ゴシック"/>
         <a:font script="Hang" typeface="맑은 고딕"/>
-        <a:font script="Hans" typeface="宋体"/>
+        <a:font script="Hans" typeface="等线"/>
         <a:font script="Hant" typeface="新細明體"/>
         <a:font script="Arab" typeface="Arial"/>
         <a:font script="Hebr" typeface="Arial"/>
@@ -11104,9 +11113,26 @@
         <a:font script="Viet" typeface="Arial"/>
         <a:font script="Uigh" typeface="Microsoft Uighur"/>
         <a:font script="Geor" typeface="Sylfaen"/>
+        <a:font script="Armn" typeface="Arial"/>
+        <a:font script="Bugi" typeface="Leelawadee UI"/>
+        <a:font script="Bopo" typeface="Microsoft JhengHei"/>
+        <a:font script="Java" typeface="Javanese Text"/>
+        <a:font script="Lisu" typeface="Segoe UI"/>
+        <a:font script="Mymr" typeface="Myanmar Text"/>
+        <a:font script="Nkoo" typeface="Ebrima"/>
+        <a:font script="Olck" typeface="Nirmala UI"/>
+        <a:font script="Osma" typeface="Ebrima"/>
+        <a:font script="Phag" typeface="Phagspa"/>
+        <a:font script="Syrn" typeface="Estrangelo Edessa"/>
+        <a:font script="Syrj" typeface="Estrangelo Edessa"/>
+        <a:font script="Syre" typeface="Estrangelo Edessa"/>
+        <a:font script="Sora" typeface="Nirmala UI"/>
+        <a:font script="Tale" typeface="Microsoft Tai Le"/>
+        <a:font script="Talu" typeface="Microsoft New Tai Lue"/>
+        <a:font script="Tfng" typeface="Ebrima"/>
       </a:minorFont>
     </a:fontScheme>
-    <a:fmtScheme name="Circuit">
+    <a:fmtScheme name="Office">
       <a:fillStyleLst>
         <a:solidFill>
           <a:schemeClr val="phClr"/>
@@ -11115,35 +11141,49 @@
           <a:gsLst>
             <a:gs pos="0">
               <a:schemeClr val="phClr">
-                <a:tint val="58000"/>
-                <a:satMod val="108000"/>
                 <a:lumMod val="110000"/>
+                <a:satMod val="105000"/>
+                <a:tint val="67000"/>
+              </a:schemeClr>
+            </a:gs>
+            <a:gs pos="50000">
+              <a:schemeClr val="phClr">
+                <a:lumMod val="105000"/>
+                <a:satMod val="103000"/>
+                <a:tint val="73000"/>
               </a:schemeClr>
             </a:gs>
             <a:gs pos="100000">
               <a:schemeClr val="phClr">
+                <a:lumMod val="105000"/>
+                <a:satMod val="109000"/>
                 <a:tint val="81000"/>
-                <a:satMod val="109000"/>
-                <a:lumMod val="105000"/>
               </a:schemeClr>
             </a:gs>
           </a:gsLst>
-          <a:lin ang="5040000" scaled="0"/>
+          <a:lin ang="5400000" scaled="0"/>
         </a:gradFill>
         <a:gradFill rotWithShape="1">
           <a:gsLst>
             <a:gs pos="0">
               <a:schemeClr val="phClr">
+                <a:satMod val="103000"/>
+                <a:lumMod val="102000"/>
                 <a:tint val="94000"/>
-                <a:satMod val="105000"/>
-                <a:lumMod val="102000"/>
+              </a:schemeClr>
+            </a:gs>
+            <a:gs pos="50000">
+              <a:schemeClr val="phClr">
+                <a:satMod val="110000"/>
+                <a:lumMod val="100000"/>
+                <a:shade val="100000"/>
               </a:schemeClr>
             </a:gs>
             <a:gs pos="100000">
               <a:schemeClr val="phClr">
-                <a:shade val="74000"/>
-                <a:satMod val="128000"/>
-                <a:lumMod val="100000"/>
+                <a:lumMod val="99000"/>
+                <a:satMod val="120000"/>
+                <a:shade val="78000"/>
               </a:schemeClr>
             </a:gs>
           </a:gsLst>
@@ -11151,23 +11191,26 @@
         </a:gradFill>
       </a:fillStyleLst>
       <a:lnStyleLst>
-        <a:ln w="9525" cap="flat" cmpd="sng" algn="ctr">
+        <a:ln w="12700" cap="flat" cmpd="sng" algn="ctr">
           <a:solidFill>
             <a:schemeClr val="phClr"/>
           </a:solidFill>
           <a:prstDash val="solid"/>
+          <a:miter lim="800000"/>
         </a:ln>
-        <a:ln w="15875" cap="flat" cmpd="sng" algn="ctr">
+        <a:ln w="19050" cap="flat" cmpd="sng" algn="ctr">
           <a:solidFill>
             <a:schemeClr val="phClr"/>
           </a:solidFill>
           <a:prstDash val="solid"/>
+          <a:miter lim="800000"/>
         </a:ln>
-        <a:ln w="22225" cap="flat" cmpd="sng" algn="ctr">
+        <a:ln w="25400" cap="flat" cmpd="sng" algn="ctr">
           <a:solidFill>
             <a:schemeClr val="phClr"/>
           </a:solidFill>
           <a:prstDash val="solid"/>
+          <a:miter lim="800000"/>
         </a:ln>
       </a:lnStyleLst>
       <a:effectStyleLst>
@@ -11191,54 +11234,67 @@
         <a:solidFill>
           <a:schemeClr val="phClr"/>
         </a:solidFill>
+        <a:solidFill>
+          <a:schemeClr val="phClr">
+            <a:tint val="95000"/>
+            <a:satMod val="170000"/>
+          </a:schemeClr>
+        </a:solidFill>
         <a:gradFill rotWithShape="1">
           <a:gsLst>
             <a:gs pos="0">
               <a:schemeClr val="phClr">
+                <a:tint val="93000"/>
+                <a:satMod val="150000"/>
+                <a:shade val="98000"/>
+                <a:lumMod val="102000"/>
+              </a:schemeClr>
+            </a:gs>
+            <a:gs pos="50000">
+              <a:schemeClr val="phClr">
                 <a:tint val="98000"/>
-                <a:hueMod val="94000"/>
-                <a:satMod val="148000"/>
-                <a:lumMod val="150000"/>
+                <a:satMod val="130000"/>
+                <a:shade val="90000"/>
+                <a:lumMod val="103000"/>
               </a:schemeClr>
             </a:gs>
             <a:gs pos="100000">
               <a:schemeClr val="phClr">
-                <a:shade val="92000"/>
-                <a:hueMod val="104000"/>
-                <a:satMod val="140000"/>
-                <a:lumMod val="68000"/>
+                <a:shade val="63000"/>
+                <a:satMod val="120000"/>
               </a:schemeClr>
             </a:gs>
           </a:gsLst>
-          <a:lin ang="5040000" scaled="0"/>
+          <a:lin ang="5400000" scaled="0"/>
         </a:gradFill>
-        <a:blipFill>
-          <a:blip xmlns:r="http://schemas.openxmlformats.org/officeDocument/2006/relationships" r:embed="rId1">
-            <a:duotone>
-              <a:schemeClr val="phClr">
-                <a:shade val="88000"/>
-                <a:hueMod val="106000"/>
-                <a:satMod val="140000"/>
-                <a:lumMod val="54000"/>
-              </a:schemeClr>
-              <a:schemeClr val="phClr">
-                <a:tint val="98000"/>
-                <a:hueMod val="90000"/>
-                <a:satMod val="150000"/>
-                <a:lumMod val="160000"/>
-              </a:schemeClr>
-            </a:duotone>
-          </a:blip>
-          <a:stretch/>
-        </a:blipFill>
       </a:bgFillStyleLst>
     </a:fmtScheme>
   </a:themeElements>
-  <a:objectDefaults/>
+  <a:objectDefaults>
+    <a:lnDef>
+      <a:spPr/>
+      <a:bodyPr/>
+      <a:lstStyle/>
+      <a:style>
+        <a:lnRef idx="2">
+          <a:schemeClr val="accent1"/>
+        </a:lnRef>
+        <a:fillRef idx="0">
+          <a:schemeClr val="accent1"/>
+        </a:fillRef>
+        <a:effectRef idx="1">
+          <a:schemeClr val="accent1"/>
+        </a:effectRef>
+        <a:fontRef idx="minor">
+          <a:schemeClr val="tx1"/>
+        </a:fontRef>
+      </a:style>
+    </a:lnDef>
+  </a:objectDefaults>
   <a:extraClrSchemeLst/>
   <a:extLst>
     <a:ext uri="{05A4C25C-085E-4340-85A3-A5531E510DB2}">
-      <thm15:themeFamily xmlns:thm15="http://schemas.microsoft.com/office/thememl/2012/main" name="Circuit" id="{0AC2F7E7-15F5-431C-B2A2-456FE929F56C}" vid="{0911B802-464C-4241-8DD9-B60FF88E379F}"/>
+      <thm15:themeFamily xmlns:thm15="http://schemas.microsoft.com/office/thememl/2012/main" name="Office Theme" id="{2E142A2C-CD16-42D6-873A-C26D2A0506FA}" vid="{1BDDFF52-6CD6-40A5-AB3C-68EB2F1E4D0A}"/>
     </a:ext>
   </a:extLst>
 </a:theme>

</xml_diff>